<commit_message>
chore: unify repository and CLI name as runnora-docgen
</commit_message>
<xml_diff>
--- a/docs/tutorial/output/runnora-api-testing.pptx
+++ b/docs/tutorial/output/runnora-api-testing.pptx
@@ -2,26 +2,26 @@
 <file path=ppt/presentation.xml><?xml version="1.0" encoding="utf-8"?>
 <p:presentation xmlns:p="http://schemas.openxmlformats.org/presentationml/2006/main">
   <p:sldMasterIdLst>
-    <p:sldMasterId xmlns:r="http://schemas.openxmlformats.org/officeDocument/2006/relationships" id="2147483648" r:id="R15b0245d13004cb3"/>
+    <p:sldMasterId xmlns:r="http://schemas.openxmlformats.org/officeDocument/2006/relationships" id="2147483648" r:id="Re1adc56eefef496c"/>
   </p:sldMasterIdLst>
   <p:notesMasterIdLst>
-    <p:notesMasterId xmlns:r="http://schemas.openxmlformats.org/officeDocument/2006/relationships" r:id="R8a71c0debd654942"/>
+    <p:notesMasterId xmlns:r="http://schemas.openxmlformats.org/officeDocument/2006/relationships" r:id="R6b6f5351f83c42f7"/>
   </p:notesMasterIdLst>
   <p:sldIdLst>
-    <p:sldId xmlns:r="http://schemas.openxmlformats.org/officeDocument/2006/relationships" id="256" r:id="Rec83360614464da2"/>
-    <p:sldId xmlns:r="http://schemas.openxmlformats.org/officeDocument/2006/relationships" id="257" r:id="R9a372755635c4b67"/>
-    <p:sldId xmlns:r="http://schemas.openxmlformats.org/officeDocument/2006/relationships" id="258" r:id="R84aaa5443d0f48c3"/>
-    <p:sldId xmlns:r="http://schemas.openxmlformats.org/officeDocument/2006/relationships" id="259" r:id="R579c6b972597480b"/>
-    <p:sldId xmlns:r="http://schemas.openxmlformats.org/officeDocument/2006/relationships" id="260" r:id="R89f73f6f195b474d"/>
-    <p:sldId xmlns:r="http://schemas.openxmlformats.org/officeDocument/2006/relationships" id="261" r:id="Rf5305a0ba0224933"/>
-    <p:sldId xmlns:r="http://schemas.openxmlformats.org/officeDocument/2006/relationships" id="262" r:id="Ra7f0538a7e494dc8"/>
-    <p:sldId xmlns:r="http://schemas.openxmlformats.org/officeDocument/2006/relationships" id="263" r:id="R8c5e496936f74914"/>
-    <p:sldId xmlns:r="http://schemas.openxmlformats.org/officeDocument/2006/relationships" id="264" r:id="Ra02377666140493d"/>
-    <p:sldId xmlns:r="http://schemas.openxmlformats.org/officeDocument/2006/relationships" id="265" r:id="Rf813654ecc72472b"/>
-    <p:sldId xmlns:r="http://schemas.openxmlformats.org/officeDocument/2006/relationships" id="266" r:id="R2efba61f2d4e428e"/>
-    <p:sldId xmlns:r="http://schemas.openxmlformats.org/officeDocument/2006/relationships" id="267" r:id="R79774fc6390243fc"/>
-    <p:sldId xmlns:r="http://schemas.openxmlformats.org/officeDocument/2006/relationships" id="268" r:id="R12ee90ae37d242b4"/>
-    <p:sldId xmlns:r="http://schemas.openxmlformats.org/officeDocument/2006/relationships" id="269" r:id="Rf28e22f513e34e1f"/>
+    <p:sldId xmlns:r="http://schemas.openxmlformats.org/officeDocument/2006/relationships" id="256" r:id="R8bd448bef60545df"/>
+    <p:sldId xmlns:r="http://schemas.openxmlformats.org/officeDocument/2006/relationships" id="257" r:id="Rb1074ff78fa24efb"/>
+    <p:sldId xmlns:r="http://schemas.openxmlformats.org/officeDocument/2006/relationships" id="258" r:id="R088f844d9ff544d4"/>
+    <p:sldId xmlns:r="http://schemas.openxmlformats.org/officeDocument/2006/relationships" id="259" r:id="Rd697d2b2e4f54b3d"/>
+    <p:sldId xmlns:r="http://schemas.openxmlformats.org/officeDocument/2006/relationships" id="260" r:id="Rbf66ba68fc134567"/>
+    <p:sldId xmlns:r="http://schemas.openxmlformats.org/officeDocument/2006/relationships" id="261" r:id="R5a51d5ca029d40f6"/>
+    <p:sldId xmlns:r="http://schemas.openxmlformats.org/officeDocument/2006/relationships" id="262" r:id="R680644625df740aa"/>
+    <p:sldId xmlns:r="http://schemas.openxmlformats.org/officeDocument/2006/relationships" id="263" r:id="Rcc86dc6da433497d"/>
+    <p:sldId xmlns:r="http://schemas.openxmlformats.org/officeDocument/2006/relationships" id="264" r:id="Rfa9f3bcc63d34080"/>
+    <p:sldId xmlns:r="http://schemas.openxmlformats.org/officeDocument/2006/relationships" id="265" r:id="R03746e2dd17b4519"/>
+    <p:sldId xmlns:r="http://schemas.openxmlformats.org/officeDocument/2006/relationships" id="266" r:id="Rc7ec8970b6b04d35"/>
+    <p:sldId xmlns:r="http://schemas.openxmlformats.org/officeDocument/2006/relationships" id="267" r:id="R40b7db2c5a014725"/>
+    <p:sldId xmlns:r="http://schemas.openxmlformats.org/officeDocument/2006/relationships" id="268" r:id="Rb8801d20d26f4c7b"/>
+    <p:sldId xmlns:r="http://schemas.openxmlformats.org/officeDocument/2006/relationships" id="269" r:id="Raf795882f35e4a49"/>
   </p:sldIdLst>
   <p:sldSz cx="12192000" cy="6858000"/>
   <p:notesSz cx="6858000" cy="9144000"/>
@@ -540,7 +540,7 @@
           <a:lstStyle xmlns:a="http://schemas.openxmlformats.org/drawingml/2006/main"/>
           <a:p xmlns:a="http://schemas.openxmlformats.org/drawingml/2006/main">
             <a:r>
-              <a:t>Step 2とStep 9を対応させて説明する。runnora-instructionsはこのリポジトリのCLI。実行や実レスポンスの収集はしない。手順書と実行記録の役割を混同しない。</a:t>
+              <a:t>Step 2とStep 9を対応させて説明する。runnora-docgenはこのリポジトリのCLI。実行や実レスポンスの収集はしない。手順書と実行記録の役割を混同しない。</a:t>
             </a:r>
           </a:p>
           <a:p xmlns:a="http://schemas.openxmlformats.org/drawingml/2006/main">
@@ -1643,7 +1643,7 @@
   </p:cSld>
   <p:clrMap bg1="lt1" tx1="dk1" bg2="lt2" tx2="dk2" accent1="accent1" accent2="accent2" accent3="accent3" accent4="accent4" accent5="accent5" accent6="accent6" hlink="hlink" folHlink="folHlink"/>
   <p:sldLayoutIdLst>
-    <p:sldLayoutId xmlns:r="http://schemas.openxmlformats.org/officeDocument/2006/relationships" id="2147483649" r:id="Rb3952aa1017f4d83"/>
+    <p:sldLayoutId xmlns:r="http://schemas.openxmlformats.org/officeDocument/2006/relationships" id="2147483649" r:id="R6eeee1927ec74a7c"/>
   </p:sldLayoutIdLst>
   <p:txStyles>
     <p:titleStyle>
@@ -2223,6 +2223,7 @@
           <a:lstStyle xmlns:a="http://schemas.openxmlformats.org/drawingml/2006/main"/>
           <a:p xmlns:a="http://schemas.openxmlformats.org/drawingml/2006/main">
             <a:pPr>
+              <a:buNone/>
               <a:defRPr sz="3300" b="1">
                 <a:solidFill>
                   <a:srgbClr val="FFFFFF"/>
@@ -2280,6 +2281,7 @@
           <a:lstStyle xmlns:a="http://schemas.openxmlformats.org/drawingml/2006/main"/>
           <a:p xmlns:a="http://schemas.openxmlformats.org/drawingml/2006/main">
             <a:pPr>
+              <a:buNone/>
               <a:defRPr sz="1350" b="0">
                 <a:solidFill>
                   <a:srgbClr val="A7CFCD"/>
@@ -2337,6 +2339,7 @@
           <a:lstStyle xmlns:a="http://schemas.openxmlformats.org/drawingml/2006/main"/>
           <a:p xmlns:a="http://schemas.openxmlformats.org/drawingml/2006/main">
             <a:pPr>
+              <a:buNone/>
               <a:defRPr sz="4350" b="1">
                 <a:solidFill>
                   <a:srgbClr val="FFFFFF"/>
@@ -2360,6 +2363,7 @@
           </a:p>
           <a:p xmlns:a="http://schemas.openxmlformats.org/drawingml/2006/main">
             <a:pPr>
+              <a:buNone/>
               <a:defRPr sz="4350" b="1">
                 <a:solidFill>
                   <a:srgbClr val="FFFFFF"/>
@@ -2417,6 +2421,7 @@
           <a:lstStyle xmlns:a="http://schemas.openxmlformats.org/drawingml/2006/main"/>
           <a:p xmlns:a="http://schemas.openxmlformats.org/drawingml/2006/main">
             <a:pPr>
+              <a:buNone/>
               <a:defRPr sz="2250" b="0">
                 <a:solidFill>
                   <a:srgbClr val="9DD9D4"/>
@@ -2474,6 +2479,7 @@
           <a:lstStyle xmlns:a="http://schemas.openxmlformats.org/drawingml/2006/main"/>
           <a:p xmlns:a="http://schemas.openxmlformats.org/drawingml/2006/main">
             <a:pPr>
+              <a:buNone/>
               <a:defRPr sz="2025" b="0">
                 <a:solidFill>
                   <a:srgbClr val="D6E7ED"/>
@@ -2560,6 +2566,7 @@
           <a:lstStyle xmlns:a="http://schemas.openxmlformats.org/drawingml/2006/main"/>
           <a:p xmlns:a="http://schemas.openxmlformats.org/drawingml/2006/main">
             <a:pPr>
+              <a:buNone/>
               <a:defRPr sz="3300" b="1">
                 <a:solidFill>
                   <a:srgbClr val="12384B"/>
@@ -2617,6 +2624,7 @@
           <a:lstStyle xmlns:a="http://schemas.openxmlformats.org/drawingml/2006/main"/>
           <a:p xmlns:a="http://schemas.openxmlformats.org/drawingml/2006/main">
             <a:pPr>
+              <a:buNone/>
               <a:defRPr sz="1350" b="0">
                 <a:solidFill>
                   <a:srgbClr val="5B6F7D"/>
@@ -2674,6 +2682,7 @@
           <a:lstStyle xmlns:a="http://schemas.openxmlformats.org/drawingml/2006/main"/>
           <a:p xmlns:a="http://schemas.openxmlformats.org/drawingml/2006/main">
             <a:pPr>
+              <a:buNone/>
               <a:defRPr sz="2850" b="1">
                 <a:solidFill>
                   <a:srgbClr val="147D78"/>
@@ -2731,6 +2740,7 @@
           <a:lstStyle xmlns:a="http://schemas.openxmlformats.org/drawingml/2006/main"/>
           <a:p xmlns:a="http://schemas.openxmlformats.org/drawingml/2006/main">
             <a:pPr>
+              <a:buNone/>
               <a:defRPr sz="2400" b="0">
                 <a:solidFill>
                   <a:srgbClr val="24384A"/>
@@ -2788,6 +2798,7 @@
           <a:lstStyle xmlns:a="http://schemas.openxmlformats.org/drawingml/2006/main"/>
           <a:p xmlns:a="http://schemas.openxmlformats.org/drawingml/2006/main">
             <a:pPr>
+              <a:buNone/>
               <a:defRPr sz="2850" b="1">
                 <a:solidFill>
                   <a:srgbClr val="147D78"/>
@@ -2806,7 +2817,18 @@
                 <a:ea typeface="Yu Gothic"/>
                 <a:cs typeface="Yu Gothic"/>
               </a:rPr>
-              <a:t>runnora-instructions generate</a:t>
+              <a:t>runnora-docgen</a:t>
+            </a:r>
+            <a:r>
+              <a:rPr sz="2850" b="1">
+                <a:solidFill>
+                  <a:srgbClr val="147D78"/>
+                </a:solidFill>
+                <a:latin typeface="Yu Gothic"/>
+                <a:ea typeface="Yu Gothic"/>
+                <a:cs typeface="Yu Gothic"/>
+              </a:rPr>
+              <a:t> generate</a:t>
             </a:r>
           </a:p>
         </p:txBody>
@@ -2845,6 +2867,7 @@
           <a:lstStyle xmlns:a="http://schemas.openxmlformats.org/drawingml/2006/main"/>
           <a:p xmlns:a="http://schemas.openxmlformats.org/drawingml/2006/main">
             <a:pPr>
+              <a:buNone/>
               <a:defRPr sz="2400" b="0">
                 <a:solidFill>
                   <a:srgbClr val="24384A"/>
@@ -2931,6 +2954,7 @@
           <a:lstStyle xmlns:a="http://schemas.openxmlformats.org/drawingml/2006/main"/>
           <a:p xmlns:a="http://schemas.openxmlformats.org/drawingml/2006/main">
             <a:pPr>
+              <a:buNone/>
               <a:defRPr sz="3300" b="1">
                 <a:solidFill>
                   <a:srgbClr val="12384B"/>
@@ -2988,6 +3012,7 @@
           <a:lstStyle xmlns:a="http://schemas.openxmlformats.org/drawingml/2006/main"/>
           <a:p xmlns:a="http://schemas.openxmlformats.org/drawingml/2006/main">
             <a:pPr>
+              <a:buNone/>
               <a:defRPr sz="1350" b="0">
                 <a:solidFill>
                   <a:srgbClr val="5B6F7D"/>
@@ -3013,7 +3038,7 @@
       </p:sp>
       <p:graphicFrame>
         <p:nvGraphicFramePr>
-          <p:cNvPr id="7" name=""/>
+          <p:cNvPr id="9" name=""/>
           <p:cNvGraphicFramePr/>
           <p:nvPr/>
         </p:nvGraphicFramePr>
@@ -3317,6 +3342,7 @@
           <a:lstStyle xmlns:a="http://schemas.openxmlformats.org/drawingml/2006/main"/>
           <a:p xmlns:a="http://schemas.openxmlformats.org/drawingml/2006/main">
             <a:pPr>
+              <a:buNone/>
               <a:defRPr sz="2175" b="1">
                 <a:solidFill>
                   <a:srgbClr val="147D78"/>
@@ -3403,6 +3429,7 @@
           <a:lstStyle xmlns:a="http://schemas.openxmlformats.org/drawingml/2006/main"/>
           <a:p xmlns:a="http://schemas.openxmlformats.org/drawingml/2006/main">
             <a:pPr>
+              <a:buNone/>
               <a:defRPr sz="3300" b="1">
                 <a:solidFill>
                   <a:srgbClr val="12384B"/>
@@ -3460,6 +3487,7 @@
           <a:lstStyle xmlns:a="http://schemas.openxmlformats.org/drawingml/2006/main"/>
           <a:p xmlns:a="http://schemas.openxmlformats.org/drawingml/2006/main">
             <a:pPr>
+              <a:buNone/>
               <a:defRPr sz="1350" b="0">
                 <a:solidFill>
                   <a:srgbClr val="5B6F7D"/>
@@ -3517,6 +3545,7 @@
           <a:lstStyle xmlns:a="http://schemas.openxmlformats.org/drawingml/2006/main"/>
           <a:p xmlns:a="http://schemas.openxmlformats.org/drawingml/2006/main">
             <a:pPr>
+              <a:buNone/>
               <a:defRPr sz="2250" b="1">
                 <a:solidFill>
                   <a:srgbClr val="147D78"/>
@@ -3574,6 +3603,7 @@
           <a:lstStyle xmlns:a="http://schemas.openxmlformats.org/drawingml/2006/main"/>
           <a:p xmlns:a="http://schemas.openxmlformats.org/drawingml/2006/main">
             <a:pPr>
+              <a:buNone/>
               <a:defRPr sz="2250" b="0">
                 <a:solidFill>
                   <a:srgbClr val="24384A"/>
@@ -3631,6 +3661,7 @@
           <a:lstStyle xmlns:a="http://schemas.openxmlformats.org/drawingml/2006/main"/>
           <a:p xmlns:a="http://schemas.openxmlformats.org/drawingml/2006/main">
             <a:pPr>
+              <a:buNone/>
               <a:defRPr sz="2250" b="1">
                 <a:solidFill>
                   <a:srgbClr val="147D78"/>
@@ -3688,6 +3719,7 @@
           <a:lstStyle xmlns:a="http://schemas.openxmlformats.org/drawingml/2006/main"/>
           <a:p xmlns:a="http://schemas.openxmlformats.org/drawingml/2006/main">
             <a:pPr>
+              <a:buNone/>
               <a:defRPr sz="2250" b="0">
                 <a:solidFill>
                   <a:srgbClr val="24384A"/>
@@ -3745,6 +3777,7 @@
           <a:lstStyle xmlns:a="http://schemas.openxmlformats.org/drawingml/2006/main"/>
           <a:p xmlns:a="http://schemas.openxmlformats.org/drawingml/2006/main">
             <a:pPr>
+              <a:buNone/>
               <a:defRPr sz="2250" b="1">
                 <a:solidFill>
                   <a:srgbClr val="147D78"/>
@@ -3802,6 +3835,7 @@
           <a:lstStyle xmlns:a="http://schemas.openxmlformats.org/drawingml/2006/main"/>
           <a:p xmlns:a="http://schemas.openxmlformats.org/drawingml/2006/main">
             <a:pPr>
+              <a:buNone/>
               <a:defRPr sz="2250" b="0">
                 <a:solidFill>
                   <a:srgbClr val="24384A"/>
@@ -3859,6 +3893,7 @@
           <a:lstStyle xmlns:a="http://schemas.openxmlformats.org/drawingml/2006/main"/>
           <a:p xmlns:a="http://schemas.openxmlformats.org/drawingml/2006/main">
             <a:pPr>
+              <a:buNone/>
               <a:defRPr sz="2175" b="1">
                 <a:solidFill>
                   <a:srgbClr val="147D78"/>
@@ -3945,6 +3980,7 @@
           <a:lstStyle xmlns:a="http://schemas.openxmlformats.org/drawingml/2006/main"/>
           <a:p xmlns:a="http://schemas.openxmlformats.org/drawingml/2006/main">
             <a:pPr>
+              <a:buNone/>
               <a:defRPr sz="3300" b="1">
                 <a:solidFill>
                   <a:srgbClr val="12384B"/>
@@ -4002,6 +4038,7 @@
           <a:lstStyle xmlns:a="http://schemas.openxmlformats.org/drawingml/2006/main"/>
           <a:p xmlns:a="http://schemas.openxmlformats.org/drawingml/2006/main">
             <a:pPr>
+              <a:buNone/>
               <a:defRPr sz="1350" b="0">
                 <a:solidFill>
                   <a:srgbClr val="5B6F7D"/>
@@ -4059,6 +4096,7 @@
           <a:lstStyle xmlns:a="http://schemas.openxmlformats.org/drawingml/2006/main"/>
           <a:p xmlns:a="http://schemas.openxmlformats.org/drawingml/2006/main">
             <a:pPr>
+              <a:buNone/>
               <a:defRPr sz="2250" b="1">
                 <a:solidFill>
                   <a:srgbClr val="147D78"/>
@@ -4116,6 +4154,7 @@
           <a:lstStyle xmlns:a="http://schemas.openxmlformats.org/drawingml/2006/main"/>
           <a:p xmlns:a="http://schemas.openxmlformats.org/drawingml/2006/main">
             <a:pPr>
+              <a:buNone/>
               <a:defRPr sz="2250" b="0">
                 <a:solidFill>
                   <a:srgbClr val="24384A"/>
@@ -4173,6 +4212,7 @@
           <a:lstStyle xmlns:a="http://schemas.openxmlformats.org/drawingml/2006/main"/>
           <a:p xmlns:a="http://schemas.openxmlformats.org/drawingml/2006/main">
             <a:pPr>
+              <a:buNone/>
               <a:defRPr sz="2250" b="1">
                 <a:solidFill>
                   <a:srgbClr val="147D78"/>
@@ -4230,6 +4270,7 @@
           <a:lstStyle xmlns:a="http://schemas.openxmlformats.org/drawingml/2006/main"/>
           <a:p xmlns:a="http://schemas.openxmlformats.org/drawingml/2006/main">
             <a:pPr>
+              <a:buNone/>
               <a:defRPr sz="2250" b="0">
                 <a:solidFill>
                   <a:srgbClr val="24384A"/>
@@ -4287,6 +4328,7 @@
           <a:lstStyle xmlns:a="http://schemas.openxmlformats.org/drawingml/2006/main"/>
           <a:p xmlns:a="http://schemas.openxmlformats.org/drawingml/2006/main">
             <a:pPr>
+              <a:buNone/>
               <a:defRPr sz="2250" b="1">
                 <a:solidFill>
                   <a:srgbClr val="147D78"/>
@@ -4344,6 +4386,7 @@
           <a:lstStyle xmlns:a="http://schemas.openxmlformats.org/drawingml/2006/main"/>
           <a:p xmlns:a="http://schemas.openxmlformats.org/drawingml/2006/main">
             <a:pPr>
+              <a:buNone/>
               <a:defRPr sz="2250" b="0">
                 <a:solidFill>
                   <a:srgbClr val="24384A"/>
@@ -4401,6 +4444,7 @@
           <a:lstStyle xmlns:a="http://schemas.openxmlformats.org/drawingml/2006/main"/>
           <a:p xmlns:a="http://schemas.openxmlformats.org/drawingml/2006/main">
             <a:pPr>
+              <a:buNone/>
               <a:defRPr sz="2250" b="1">
                 <a:solidFill>
                   <a:srgbClr val="147D78"/>
@@ -4487,6 +4531,7 @@
           <a:lstStyle xmlns:a="http://schemas.openxmlformats.org/drawingml/2006/main"/>
           <a:p xmlns:a="http://schemas.openxmlformats.org/drawingml/2006/main">
             <a:pPr>
+              <a:buNone/>
               <a:defRPr sz="3300" b="1">
                 <a:solidFill>
                   <a:srgbClr val="FFFFFF"/>
@@ -4544,6 +4589,7 @@
           <a:lstStyle xmlns:a="http://schemas.openxmlformats.org/drawingml/2006/main"/>
           <a:p xmlns:a="http://schemas.openxmlformats.org/drawingml/2006/main">
             <a:pPr>
+              <a:buNone/>
               <a:defRPr sz="1350" b="0">
                 <a:solidFill>
                   <a:srgbClr val="A7CFCD"/>
@@ -4601,6 +4647,7 @@
           <a:lstStyle xmlns:a="http://schemas.openxmlformats.org/drawingml/2006/main"/>
           <a:p xmlns:a="http://schemas.openxmlformats.org/drawingml/2006/main">
             <a:pPr>
+              <a:buNone/>
               <a:defRPr sz="4200" b="1">
                 <a:solidFill>
                   <a:srgbClr val="FFFFFF"/>
@@ -4624,6 +4671,7 @@
           </a:p>
           <a:p xmlns:a="http://schemas.openxmlformats.org/drawingml/2006/main">
             <a:pPr>
+              <a:buNone/>
               <a:defRPr sz="4200" b="1">
                 <a:solidFill>
                   <a:srgbClr val="FFFFFF"/>
@@ -4681,6 +4729,7 @@
           <a:lstStyle xmlns:a="http://schemas.openxmlformats.org/drawingml/2006/main"/>
           <a:p xmlns:a="http://schemas.openxmlformats.org/drawingml/2006/main">
             <a:pPr>
+              <a:buNone/>
               <a:defRPr sz="2850" b="1">
                 <a:solidFill>
                   <a:srgbClr val="9DD9D4"/>
@@ -4738,6 +4787,7 @@
           <a:lstStyle xmlns:a="http://schemas.openxmlformats.org/drawingml/2006/main"/>
           <a:p xmlns:a="http://schemas.openxmlformats.org/drawingml/2006/main">
             <a:pPr>
+              <a:buNone/>
               <a:defRPr sz="2100" b="0">
                 <a:solidFill>
                   <a:srgbClr val="D6E7ED"/>
@@ -4761,6 +4811,7 @@
           </a:p>
           <a:p xmlns:a="http://schemas.openxmlformats.org/drawingml/2006/main">
             <a:pPr>
+              <a:buNone/>
               <a:defRPr sz="2100" b="0">
                 <a:solidFill>
                   <a:srgbClr val="D6E7ED"/>
@@ -4847,6 +4898,7 @@
           <a:lstStyle xmlns:a="http://schemas.openxmlformats.org/drawingml/2006/main"/>
           <a:p xmlns:a="http://schemas.openxmlformats.org/drawingml/2006/main">
             <a:pPr>
+              <a:buNone/>
               <a:defRPr sz="3300" b="1">
                 <a:solidFill>
                   <a:srgbClr val="12384B"/>
@@ -4904,6 +4956,7 @@
           <a:lstStyle xmlns:a="http://schemas.openxmlformats.org/drawingml/2006/main"/>
           <a:p xmlns:a="http://schemas.openxmlformats.org/drawingml/2006/main">
             <a:pPr>
+              <a:buNone/>
               <a:defRPr sz="1350" b="0">
                 <a:solidFill>
                   <a:srgbClr val="5B6F7D"/>
@@ -4961,6 +5014,7 @@
           <a:lstStyle xmlns:a="http://schemas.openxmlformats.org/drawingml/2006/main"/>
           <a:p xmlns:a="http://schemas.openxmlformats.org/drawingml/2006/main">
             <a:pPr>
+              <a:buNone/>
               <a:defRPr sz="2250" b="1">
                 <a:solidFill>
                   <a:srgbClr val="147D78"/>
@@ -5018,6 +5072,7 @@
           <a:lstStyle xmlns:a="http://schemas.openxmlformats.org/drawingml/2006/main"/>
           <a:p xmlns:a="http://schemas.openxmlformats.org/drawingml/2006/main">
             <a:pPr>
+              <a:buNone/>
               <a:defRPr sz="2250" b="0">
                 <a:solidFill>
                   <a:srgbClr val="24384A"/>
@@ -5075,6 +5130,7 @@
           <a:lstStyle xmlns:a="http://schemas.openxmlformats.org/drawingml/2006/main"/>
           <a:p xmlns:a="http://schemas.openxmlformats.org/drawingml/2006/main">
             <a:pPr>
+              <a:buNone/>
               <a:defRPr sz="2250" b="1">
                 <a:solidFill>
                   <a:srgbClr val="147D78"/>
@@ -5132,6 +5188,7 @@
           <a:lstStyle xmlns:a="http://schemas.openxmlformats.org/drawingml/2006/main"/>
           <a:p xmlns:a="http://schemas.openxmlformats.org/drawingml/2006/main">
             <a:pPr>
+              <a:buNone/>
               <a:defRPr sz="2250" b="0">
                 <a:solidFill>
                   <a:srgbClr val="24384A"/>
@@ -5189,6 +5246,7 @@
           <a:lstStyle xmlns:a="http://schemas.openxmlformats.org/drawingml/2006/main"/>
           <a:p xmlns:a="http://schemas.openxmlformats.org/drawingml/2006/main">
             <a:pPr>
+              <a:buNone/>
               <a:defRPr sz="2250" b="1">
                 <a:solidFill>
                   <a:srgbClr val="147D78"/>
@@ -5246,6 +5304,7 @@
           <a:lstStyle xmlns:a="http://schemas.openxmlformats.org/drawingml/2006/main"/>
           <a:p xmlns:a="http://schemas.openxmlformats.org/drawingml/2006/main">
             <a:pPr>
+              <a:buNone/>
               <a:defRPr sz="2250" b="0">
                 <a:solidFill>
                   <a:srgbClr val="24384A"/>
@@ -5303,6 +5362,7 @@
           <a:lstStyle xmlns:a="http://schemas.openxmlformats.org/drawingml/2006/main"/>
           <a:p xmlns:a="http://schemas.openxmlformats.org/drawingml/2006/main">
             <a:pPr>
+              <a:buNone/>
               <a:defRPr sz="2250" b="1">
                 <a:solidFill>
                   <a:srgbClr val="147D78"/>
@@ -5389,6 +5449,7 @@
           <a:lstStyle xmlns:a="http://schemas.openxmlformats.org/drawingml/2006/main"/>
           <a:p xmlns:a="http://schemas.openxmlformats.org/drawingml/2006/main">
             <a:pPr>
+              <a:buNone/>
               <a:defRPr sz="3300" b="1">
                 <a:solidFill>
                   <a:srgbClr val="12384B"/>
@@ -5446,6 +5507,7 @@
           <a:lstStyle xmlns:a="http://schemas.openxmlformats.org/drawingml/2006/main"/>
           <a:p xmlns:a="http://schemas.openxmlformats.org/drawingml/2006/main">
             <a:pPr>
+              <a:buNone/>
               <a:defRPr sz="1350" b="0">
                 <a:solidFill>
                   <a:srgbClr val="5B6F7D"/>
@@ -5471,7 +5533,7 @@
       </p:sp>
       <p:graphicFrame>
         <p:nvGraphicFramePr>
-          <p:cNvPr id="7" name=""/>
+          <p:cNvPr id="9" name=""/>
           <p:cNvGraphicFramePr/>
           <p:nvPr/>
         </p:nvGraphicFramePr>
@@ -5822,6 +5884,7 @@
           <a:lstStyle xmlns:a="http://schemas.openxmlformats.org/drawingml/2006/main"/>
           <a:p xmlns:a="http://schemas.openxmlformats.org/drawingml/2006/main">
             <a:pPr>
+              <a:buNone/>
               <a:defRPr sz="2250" b="1">
                 <a:solidFill>
                   <a:srgbClr val="147D78"/>
@@ -5908,6 +5971,7 @@
           <a:lstStyle xmlns:a="http://schemas.openxmlformats.org/drawingml/2006/main"/>
           <a:p xmlns:a="http://schemas.openxmlformats.org/drawingml/2006/main">
             <a:pPr>
+              <a:buNone/>
               <a:defRPr sz="3300" b="1">
                 <a:solidFill>
                   <a:srgbClr val="12384B"/>
@@ -5965,6 +6029,7 @@
           <a:lstStyle xmlns:a="http://schemas.openxmlformats.org/drawingml/2006/main"/>
           <a:p xmlns:a="http://schemas.openxmlformats.org/drawingml/2006/main">
             <a:pPr>
+              <a:buNone/>
               <a:defRPr sz="1350" b="0">
                 <a:solidFill>
                   <a:srgbClr val="5B6F7D"/>
@@ -6022,6 +6087,7 @@
           <a:lstStyle xmlns:a="http://schemas.openxmlformats.org/drawingml/2006/main"/>
           <a:p xmlns:a="http://schemas.openxmlformats.org/drawingml/2006/main">
             <a:pPr>
+              <a:buNone/>
               <a:defRPr sz="2250" b="1">
                 <a:solidFill>
                   <a:srgbClr val="147D78"/>
@@ -6079,6 +6145,7 @@
           <a:lstStyle xmlns:a="http://schemas.openxmlformats.org/drawingml/2006/main"/>
           <a:p xmlns:a="http://schemas.openxmlformats.org/drawingml/2006/main">
             <a:pPr>
+              <a:buNone/>
               <a:defRPr sz="2250" b="0">
                 <a:solidFill>
                   <a:srgbClr val="24384A"/>
@@ -6136,6 +6203,7 @@
           <a:lstStyle xmlns:a="http://schemas.openxmlformats.org/drawingml/2006/main"/>
           <a:p xmlns:a="http://schemas.openxmlformats.org/drawingml/2006/main">
             <a:pPr>
+              <a:buNone/>
               <a:defRPr sz="2250" b="1">
                 <a:solidFill>
                   <a:srgbClr val="147D78"/>
@@ -6193,6 +6261,7 @@
           <a:lstStyle xmlns:a="http://schemas.openxmlformats.org/drawingml/2006/main"/>
           <a:p xmlns:a="http://schemas.openxmlformats.org/drawingml/2006/main">
             <a:pPr>
+              <a:buNone/>
               <a:defRPr sz="2250" b="0">
                 <a:solidFill>
                   <a:srgbClr val="24384A"/>
@@ -6250,6 +6319,7 @@
           <a:lstStyle xmlns:a="http://schemas.openxmlformats.org/drawingml/2006/main"/>
           <a:p xmlns:a="http://schemas.openxmlformats.org/drawingml/2006/main">
             <a:pPr>
+              <a:buNone/>
               <a:defRPr sz="2250" b="1">
                 <a:solidFill>
                   <a:srgbClr val="147D78"/>
@@ -6307,6 +6377,7 @@
           <a:lstStyle xmlns:a="http://schemas.openxmlformats.org/drawingml/2006/main"/>
           <a:p xmlns:a="http://schemas.openxmlformats.org/drawingml/2006/main">
             <a:pPr>
+              <a:buNone/>
               <a:defRPr sz="2250" b="0">
                 <a:solidFill>
                   <a:srgbClr val="24384A"/>
@@ -6364,6 +6435,7 @@
           <a:lstStyle xmlns:a="http://schemas.openxmlformats.org/drawingml/2006/main"/>
           <a:p xmlns:a="http://schemas.openxmlformats.org/drawingml/2006/main">
             <a:pPr>
+              <a:buNone/>
               <a:defRPr sz="2250" b="1">
                 <a:solidFill>
                   <a:srgbClr val="147D78"/>
@@ -6421,6 +6493,7 @@
           <a:lstStyle xmlns:a="http://schemas.openxmlformats.org/drawingml/2006/main"/>
           <a:p xmlns:a="http://schemas.openxmlformats.org/drawingml/2006/main">
             <a:pPr>
+              <a:buNone/>
               <a:defRPr sz="2250" b="0">
                 <a:solidFill>
                   <a:srgbClr val="24384A"/>
@@ -6507,6 +6580,7 @@
           <a:lstStyle xmlns:a="http://schemas.openxmlformats.org/drawingml/2006/main"/>
           <a:p xmlns:a="http://schemas.openxmlformats.org/drawingml/2006/main">
             <a:pPr>
+              <a:buNone/>
               <a:defRPr sz="3300" b="1">
                 <a:solidFill>
                   <a:srgbClr val="12384B"/>
@@ -6564,6 +6638,7 @@
           <a:lstStyle xmlns:a="http://schemas.openxmlformats.org/drawingml/2006/main"/>
           <a:p xmlns:a="http://schemas.openxmlformats.org/drawingml/2006/main">
             <a:pPr>
+              <a:buNone/>
               <a:defRPr sz="1350" b="0">
                 <a:solidFill>
                   <a:srgbClr val="5B6F7D"/>
@@ -6621,6 +6696,7 @@
           <a:lstStyle xmlns:a="http://schemas.openxmlformats.org/drawingml/2006/main"/>
           <a:p xmlns:a="http://schemas.openxmlformats.org/drawingml/2006/main">
             <a:pPr>
+              <a:buNone/>
               <a:defRPr sz="2550" b="1">
                 <a:solidFill>
                   <a:srgbClr val="147D78"/>
@@ -6646,7 +6722,7 @@
       </p:sp>
       <p:graphicFrame>
         <p:nvGraphicFramePr>
-          <p:cNvPr id="9" name=""/>
+          <p:cNvPr id="11" name=""/>
           <p:cNvGraphicFramePr/>
           <p:nvPr/>
         </p:nvGraphicFramePr>
@@ -6949,6 +7025,7 @@
           <a:lstStyle xmlns:a="http://schemas.openxmlformats.org/drawingml/2006/main"/>
           <a:p xmlns:a="http://schemas.openxmlformats.org/drawingml/2006/main">
             <a:pPr>
+              <a:buNone/>
               <a:defRPr sz="2175" b="1">
                 <a:solidFill>
                   <a:srgbClr val="12384B"/>
@@ -7035,6 +7112,7 @@
           <a:lstStyle xmlns:a="http://schemas.openxmlformats.org/drawingml/2006/main"/>
           <a:p xmlns:a="http://schemas.openxmlformats.org/drawingml/2006/main">
             <a:pPr>
+              <a:buNone/>
               <a:defRPr sz="3300" b="1">
                 <a:solidFill>
                   <a:srgbClr val="12384B"/>
@@ -7092,6 +7170,7 @@
           <a:lstStyle xmlns:a="http://schemas.openxmlformats.org/drawingml/2006/main"/>
           <a:p xmlns:a="http://schemas.openxmlformats.org/drawingml/2006/main">
             <a:pPr>
+              <a:buNone/>
               <a:defRPr sz="1350" b="0">
                 <a:solidFill>
                   <a:srgbClr val="5B6F7D"/>
@@ -7149,6 +7228,7 @@
           <a:lstStyle xmlns:a="http://schemas.openxmlformats.org/drawingml/2006/main"/>
           <a:p xmlns:a="http://schemas.openxmlformats.org/drawingml/2006/main">
             <a:pPr>
+              <a:buNone/>
               <a:defRPr sz="2250" b="0">
                 <a:solidFill>
                   <a:srgbClr val="24384A"/>
@@ -7172,6 +7252,7 @@
           </a:p>
           <a:p xmlns:a="http://schemas.openxmlformats.org/drawingml/2006/main">
             <a:pPr>
+              <a:buNone/>
               <a:defRPr sz="2250" b="0">
                 <a:solidFill>
                   <a:srgbClr val="24384A"/>
@@ -7195,6 +7276,7 @@
           </a:p>
           <a:p xmlns:a="http://schemas.openxmlformats.org/drawingml/2006/main">
             <a:pPr>
+              <a:buNone/>
               <a:defRPr sz="2250" b="0">
                 <a:solidFill>
                   <a:srgbClr val="24384A"/>
@@ -7218,6 +7300,7 @@
           </a:p>
           <a:p xmlns:a="http://schemas.openxmlformats.org/drawingml/2006/main">
             <a:pPr>
+              <a:buNone/>
               <a:defRPr sz="2250" b="0">
                 <a:solidFill>
                   <a:srgbClr val="24384A"/>
@@ -7241,6 +7324,7 @@
           </a:p>
           <a:p xmlns:a="http://schemas.openxmlformats.org/drawingml/2006/main">
             <a:pPr>
+              <a:buNone/>
               <a:defRPr sz="2250" b="0">
                 <a:solidFill>
                   <a:srgbClr val="24384A"/>
@@ -7264,6 +7348,7 @@
           </a:p>
           <a:p xmlns:a="http://schemas.openxmlformats.org/drawingml/2006/main">
             <a:pPr>
+              <a:buNone/>
               <a:defRPr sz="2250" b="0">
                 <a:solidFill>
                   <a:srgbClr val="24384A"/>
@@ -7321,6 +7406,7 @@
           <a:lstStyle xmlns:a="http://schemas.openxmlformats.org/drawingml/2006/main"/>
           <a:p xmlns:a="http://schemas.openxmlformats.org/drawingml/2006/main">
             <a:pPr>
+              <a:buNone/>
               <a:defRPr sz="2175" b="1">
                 <a:solidFill>
                   <a:srgbClr val="147D78"/>
@@ -7349,6 +7435,7 @@
           </a:p>
           <a:p xmlns:a="http://schemas.openxmlformats.org/drawingml/2006/main">
             <a:pPr>
+              <a:buNone/>
               <a:defRPr sz="2175" b="1">
                 <a:solidFill>
                   <a:srgbClr val="147D78"/>
@@ -7377,6 +7464,7 @@
           </a:p>
           <a:p xmlns:a="http://schemas.openxmlformats.org/drawingml/2006/main">
             <a:pPr>
+              <a:buNone/>
               <a:defRPr sz="2175" b="1">
                 <a:solidFill>
                   <a:srgbClr val="147D78"/>
@@ -7434,6 +7522,7 @@
           <a:lstStyle xmlns:a="http://schemas.openxmlformats.org/drawingml/2006/main"/>
           <a:p xmlns:a="http://schemas.openxmlformats.org/drawingml/2006/main">
             <a:pPr>
+              <a:buNone/>
               <a:defRPr sz="1800" b="0">
                 <a:solidFill>
                   <a:srgbClr val="5B6F7D"/>
@@ -7520,6 +7609,7 @@
           <a:lstStyle xmlns:a="http://schemas.openxmlformats.org/drawingml/2006/main"/>
           <a:p xmlns:a="http://schemas.openxmlformats.org/drawingml/2006/main">
             <a:pPr>
+              <a:buNone/>
               <a:defRPr sz="3300" b="1">
                 <a:solidFill>
                   <a:srgbClr val="12384B"/>
@@ -7577,6 +7667,7 @@
           <a:lstStyle xmlns:a="http://schemas.openxmlformats.org/drawingml/2006/main"/>
           <a:p xmlns:a="http://schemas.openxmlformats.org/drawingml/2006/main">
             <a:pPr>
+              <a:buNone/>
               <a:defRPr sz="1350" b="0">
                 <a:solidFill>
                   <a:srgbClr val="5B6F7D"/>
@@ -7634,6 +7725,7 @@
           <a:lstStyle xmlns:a="http://schemas.openxmlformats.org/drawingml/2006/main"/>
           <a:p xmlns:a="http://schemas.openxmlformats.org/drawingml/2006/main">
             <a:pPr>
+              <a:buNone/>
               <a:defRPr sz="2175" b="1">
                 <a:solidFill>
                   <a:srgbClr val="147D78"/>
@@ -7691,6 +7783,7 @@
           <a:lstStyle xmlns:a="http://schemas.openxmlformats.org/drawingml/2006/main"/>
           <a:p xmlns:a="http://schemas.openxmlformats.org/drawingml/2006/main">
             <a:pPr>
+              <a:buNone/>
               <a:defRPr sz="2325" b="0">
                 <a:solidFill>
                   <a:srgbClr val="24384A"/>
@@ -7748,6 +7841,7 @@
           <a:lstStyle xmlns:a="http://schemas.openxmlformats.org/drawingml/2006/main"/>
           <a:p xmlns:a="http://schemas.openxmlformats.org/drawingml/2006/main">
             <a:pPr>
+              <a:buNone/>
               <a:defRPr sz="2175" b="1">
                 <a:solidFill>
                   <a:srgbClr val="147D78"/>
@@ -7805,6 +7899,7 @@
           <a:lstStyle xmlns:a="http://schemas.openxmlformats.org/drawingml/2006/main"/>
           <a:p xmlns:a="http://schemas.openxmlformats.org/drawingml/2006/main">
             <a:pPr>
+              <a:buNone/>
               <a:defRPr sz="2175" b="0">
                 <a:solidFill>
                   <a:srgbClr val="24384A"/>
@@ -7862,6 +7957,7 @@
           <a:lstStyle xmlns:a="http://schemas.openxmlformats.org/drawingml/2006/main"/>
           <a:p xmlns:a="http://schemas.openxmlformats.org/drawingml/2006/main">
             <a:pPr>
+              <a:buNone/>
               <a:defRPr sz="2025" b="1">
                 <a:solidFill>
                   <a:srgbClr val="12384B"/>
@@ -7948,6 +8044,7 @@
           <a:lstStyle xmlns:a="http://schemas.openxmlformats.org/drawingml/2006/main"/>
           <a:p xmlns:a="http://schemas.openxmlformats.org/drawingml/2006/main">
             <a:pPr>
+              <a:buNone/>
               <a:defRPr sz="3300" b="1">
                 <a:solidFill>
                   <a:srgbClr val="FFFFFF"/>
@@ -8005,6 +8102,7 @@
           <a:lstStyle xmlns:a="http://schemas.openxmlformats.org/drawingml/2006/main"/>
           <a:p xmlns:a="http://schemas.openxmlformats.org/drawingml/2006/main">
             <a:pPr>
+              <a:buNone/>
               <a:defRPr sz="1350" b="0">
                 <a:solidFill>
                   <a:srgbClr val="A7CFCD"/>
@@ -8062,6 +8160,7 @@
           <a:lstStyle xmlns:a="http://schemas.openxmlformats.org/drawingml/2006/main"/>
           <a:p xmlns:a="http://schemas.openxmlformats.org/drawingml/2006/main">
             <a:pPr>
+              <a:buNone/>
               <a:defRPr sz="2250" b="1">
                 <a:solidFill>
                   <a:srgbClr val="8DDBD4"/>
@@ -8119,6 +8218,7 @@
           <a:lstStyle xmlns:a="http://schemas.openxmlformats.org/drawingml/2006/main"/>
           <a:p xmlns:a="http://schemas.openxmlformats.org/drawingml/2006/main">
             <a:pPr>
+              <a:buNone/>
               <a:defRPr sz="2250" b="0">
                 <a:solidFill>
                   <a:srgbClr val="FFFFFF"/>
@@ -8176,6 +8276,7 @@
           <a:lstStyle xmlns:a="http://schemas.openxmlformats.org/drawingml/2006/main"/>
           <a:p xmlns:a="http://schemas.openxmlformats.org/drawingml/2006/main">
             <a:pPr>
+              <a:buNone/>
               <a:defRPr sz="2250" b="1">
                 <a:solidFill>
                   <a:srgbClr val="8DDBD4"/>
@@ -8233,6 +8334,7 @@
           <a:lstStyle xmlns:a="http://schemas.openxmlformats.org/drawingml/2006/main"/>
           <a:p xmlns:a="http://schemas.openxmlformats.org/drawingml/2006/main">
             <a:pPr>
+              <a:buNone/>
               <a:defRPr sz="2250" b="0">
                 <a:solidFill>
                   <a:srgbClr val="FFFFFF"/>
@@ -8290,6 +8392,7 @@
           <a:lstStyle xmlns:a="http://schemas.openxmlformats.org/drawingml/2006/main"/>
           <a:p xmlns:a="http://schemas.openxmlformats.org/drawingml/2006/main">
             <a:pPr>
+              <a:buNone/>
               <a:defRPr sz="2250" b="1">
                 <a:solidFill>
                   <a:srgbClr val="8DDBD4"/>
@@ -8347,6 +8450,7 @@
           <a:lstStyle xmlns:a="http://schemas.openxmlformats.org/drawingml/2006/main"/>
           <a:p xmlns:a="http://schemas.openxmlformats.org/drawingml/2006/main">
             <a:pPr>
+              <a:buNone/>
               <a:defRPr sz="2250" b="0">
                 <a:solidFill>
                   <a:srgbClr val="FFFFFF"/>
@@ -8404,6 +8508,7 @@
           <a:lstStyle xmlns:a="http://schemas.openxmlformats.org/drawingml/2006/main"/>
           <a:p xmlns:a="http://schemas.openxmlformats.org/drawingml/2006/main">
             <a:pPr>
+              <a:buNone/>
               <a:defRPr sz="2250" b="1">
                 <a:solidFill>
                   <a:srgbClr val="9DD9D4"/>
@@ -8490,6 +8595,7 @@
           <a:lstStyle xmlns:a="http://schemas.openxmlformats.org/drawingml/2006/main"/>
           <a:p xmlns:a="http://schemas.openxmlformats.org/drawingml/2006/main">
             <a:pPr>
+              <a:buNone/>
               <a:defRPr sz="3300" b="1">
                 <a:solidFill>
                   <a:srgbClr val="12384B"/>
@@ -8547,6 +8653,7 @@
           <a:lstStyle xmlns:a="http://schemas.openxmlformats.org/drawingml/2006/main"/>
           <a:p xmlns:a="http://schemas.openxmlformats.org/drawingml/2006/main">
             <a:pPr>
+              <a:buNone/>
               <a:defRPr sz="1350" b="0">
                 <a:solidFill>
                   <a:srgbClr val="5B6F7D"/>
@@ -8604,6 +8711,7 @@
           <a:lstStyle xmlns:a="http://schemas.openxmlformats.org/drawingml/2006/main"/>
           <a:p xmlns:a="http://schemas.openxmlformats.org/drawingml/2006/main">
             <a:pPr>
+              <a:buNone/>
               <a:defRPr sz="2250" b="1">
                 <a:solidFill>
                   <a:srgbClr val="147D78"/>
@@ -8661,6 +8769,7 @@
           <a:lstStyle xmlns:a="http://schemas.openxmlformats.org/drawingml/2006/main"/>
           <a:p xmlns:a="http://schemas.openxmlformats.org/drawingml/2006/main">
             <a:pPr>
+              <a:buNone/>
               <a:defRPr sz="2250" b="0">
                 <a:solidFill>
                   <a:srgbClr val="24384A"/>
@@ -8718,6 +8827,7 @@
           <a:lstStyle xmlns:a="http://schemas.openxmlformats.org/drawingml/2006/main"/>
           <a:p xmlns:a="http://schemas.openxmlformats.org/drawingml/2006/main">
             <a:pPr>
+              <a:buNone/>
               <a:defRPr sz="2250" b="1">
                 <a:solidFill>
                   <a:srgbClr val="147D78"/>
@@ -8775,6 +8885,7 @@
           <a:lstStyle xmlns:a="http://schemas.openxmlformats.org/drawingml/2006/main"/>
           <a:p xmlns:a="http://schemas.openxmlformats.org/drawingml/2006/main">
             <a:pPr>
+              <a:buNone/>
               <a:defRPr sz="2250" b="0">
                 <a:solidFill>
                   <a:srgbClr val="24384A"/>
@@ -8832,6 +8943,7 @@
           <a:lstStyle xmlns:a="http://schemas.openxmlformats.org/drawingml/2006/main"/>
           <a:p xmlns:a="http://schemas.openxmlformats.org/drawingml/2006/main">
             <a:pPr>
+              <a:buNone/>
               <a:defRPr sz="2250" b="1">
                 <a:solidFill>
                   <a:srgbClr val="147D78"/>
@@ -8889,6 +9001,7 @@
           <a:lstStyle xmlns:a="http://schemas.openxmlformats.org/drawingml/2006/main"/>
           <a:p xmlns:a="http://schemas.openxmlformats.org/drawingml/2006/main">
             <a:pPr>
+              <a:buNone/>
               <a:defRPr sz="2250" b="0">
                 <a:solidFill>
                   <a:srgbClr val="24384A"/>
@@ -8946,6 +9059,7 @@
           <a:lstStyle xmlns:a="http://schemas.openxmlformats.org/drawingml/2006/main"/>
           <a:p xmlns:a="http://schemas.openxmlformats.org/drawingml/2006/main">
             <a:pPr>
+              <a:buNone/>
               <a:defRPr sz="2175" b="1">
                 <a:solidFill>
                   <a:srgbClr val="147D78"/>

</xml_diff>